<commit_message>
ajout du déploiement des images et du modèle dans spark-master
</commit_message>
<xml_diff>
--- a/8 - NSparkAvancé - Analyse.pptx
+++ b/8 - NSparkAvancé - Analyse.pptx
@@ -218,7 +218,7 @@
           <a:p>
             <a:fld id="{6DEFCF4C-C656-4173-9B19-E1AF5C686E36}" type="datetimeFigureOut">
               <a:rPr lang="fr-FR" smtClean="0"/>
-              <a:t>20/12/2025</a:t>
+              <a:t>29/09/2026</a:t>
             </a:fld>
             <a:endParaRPr lang="fr-FR"/>
           </a:p>
@@ -1656,7 +1656,7 @@
           <a:p>
             <a:fld id="{1D8BD707-D9CF-40AE-B4C6-C98DA3205C09}" type="datetimeFigureOut">
               <a:rPr lang="en-US"/>
-              <a:t>12/20/2025</a:t>
+              <a:t>9/29/2026</a:t>
             </a:fld>
             <a:endParaRPr lang="en-US"/>
           </a:p>
@@ -1848,7 +1848,7 @@
           <a:p>
             <a:fld id="{1D8BD707-D9CF-40AE-B4C6-C98DA3205C09}" type="datetimeFigureOut">
               <a:rPr lang="en-US"/>
-              <a:t>12/20/2025</a:t>
+              <a:t>9/29/2026</a:t>
             </a:fld>
             <a:endParaRPr lang="en-US"/>
           </a:p>
@@ -2079,7 +2079,7 @@
           <a:p>
             <a:fld id="{1D8BD707-D9CF-40AE-B4C6-C98DA3205C09}" type="datetimeFigureOut">
               <a:rPr lang="en-US"/>
-              <a:t>12/20/2025</a:t>
+              <a:t>9/29/2026</a:t>
             </a:fld>
             <a:endParaRPr lang="en-US"/>
           </a:p>
@@ -2281,7 +2281,7 @@
           <a:p>
             <a:fld id="{1D8BD707-D9CF-40AE-B4C6-C98DA3205C09}" type="datetimeFigureOut">
               <a:rPr lang="en-US"/>
-              <a:t>12/20/2025</a:t>
+              <a:t>9/29/2026</a:t>
             </a:fld>
             <a:endParaRPr lang="en-US"/>
           </a:p>
@@ -2417,7 +2417,7 @@
           <a:p>
             <a:fld id="{1D8BD707-D9CF-40AE-B4C6-C98DA3205C09}" type="datetimeFigureOut">
               <a:rPr lang="en-US"/>
-              <a:t>12/20/2025</a:t>
+              <a:t>9/29/2026</a:t>
             </a:fld>
             <a:endParaRPr lang="en-US"/>
           </a:p>
@@ -2519,7 +2519,7 @@
           <a:p>
             <a:fld id="{FE69C2FC-FDFD-4827-B361-612217FFD460}" type="datetimeFigureOut">
               <a:rPr lang="fr-FR" smtClean="0"/>
-              <a:t>20/12/2025</a:t>
+              <a:t>29/09/2026</a:t>
             </a:fld>
             <a:endParaRPr lang="fr-FR"/>
           </a:p>
@@ -3031,7 +3031,7 @@
           <a:p>
             <a:fld id="{1D8BD707-D9CF-40AE-B4C6-C98DA3205C09}" type="datetimeFigureOut">
               <a:rPr lang="en-US"/>
-              <a:t>12/20/2025</a:t>
+              <a:t>9/29/2026</a:t>
             </a:fld>
             <a:endParaRPr lang="en-US"/>
           </a:p>
@@ -4015,34 +4015,7 @@
                 <a:ea typeface="DengXian" panose="02010600030101010101" pitchFamily="2" charset="-122"/>
                 <a:cs typeface="Times New Roman" panose="02020603050405020304" pitchFamily="18" charset="0"/>
               </a:rPr>
-              <a:t>Intégration </a:t>
-            </a:r>
-            <a:r>
-              <a:rPr kumimoji="0" lang="fr-FR" b="1" i="0" u="none" strike="noStrike" kern="1200" cap="none" spc="0" normalizeH="0" baseline="0" noProof="0" dirty="0" err="1">
-                <a:ln>
-                  <a:noFill/>
-                </a:ln>
-                <a:solidFill>
-                  <a:srgbClr val="17375E"/>
-                </a:solidFill>
-                <a:uLnTx/>
-                <a:uFillTx/>
-                <a:latin typeface="Trebuchet MS" panose="020B0603020202020204" pitchFamily="34" charset="0"/>
-                <a:ea typeface="DengXian" panose="02010600030101010101" pitchFamily="2" charset="-122"/>
-                <a:cs typeface="Times New Roman" panose="02020603050405020304" pitchFamily="18" charset="0"/>
-              </a:rPr>
-              <a:t>Kaf</a:t>
-            </a:r>
-            <a:r>
-              <a:rPr lang="fr-FR" b="1" dirty="0">
-                <a:solidFill>
-                  <a:srgbClr val="17375E"/>
-                </a:solidFill>
-                <a:latin typeface="Trebuchet MS" panose="020B0603020202020204" pitchFamily="34" charset="0"/>
-                <a:ea typeface="DengXian" panose="02010600030101010101" pitchFamily="2" charset="-122"/>
-                <a:cs typeface="Times New Roman" panose="02020603050405020304" pitchFamily="18" charset="0"/>
-              </a:rPr>
-              <a:t>ka</a:t>
+              <a:t>Analyse</a:t>
             </a:r>
             <a:endParaRPr kumimoji="0" lang="fr-FR" sz="1600" b="1" i="0" u="none" strike="noStrike" kern="1200" cap="none" spc="0" normalizeH="0" baseline="0" noProof="0" dirty="0">
               <a:ln>
@@ -14829,14 +14802,13 @@
               <a:t>marque_i</a:t>
             </a:r>
             <a:r>
-              <a:rPr lang="fr-FR" sz="1000" b="0" dirty="0">
-                <a:solidFill>
-                  <a:srgbClr val="98C379"/>
-                </a:solidFill>
-                <a:effectLst/>
-                <a:latin typeface="Consolas" panose="020B0609020204030204" pitchFamily="49" charset="0"/>
-              </a:rPr>
-              <a:t>’</a:t>
+              <a:rPr lang="fr-FR" sz="1000" dirty="0">
+                <a:solidFill>
+                  <a:srgbClr val="98C379"/>
+                </a:solidFill>
+                <a:latin typeface="Consolas" panose="020B0609020204030204" pitchFamily="49" charset="0"/>
+              </a:rPr>
+              <a:t>'</a:t>
             </a:r>
             <a:r>
               <a:rPr lang="fr-FR" sz="1000" b="0" dirty="0">
@@ -16925,14 +16897,13 @@
               <a:t>pays_ohe</a:t>
             </a:r>
             <a:r>
-              <a:rPr lang="fr-FR" sz="1000" b="0" dirty="0">
-                <a:solidFill>
-                  <a:srgbClr val="98C379"/>
-                </a:solidFill>
-                <a:effectLst/>
-                <a:latin typeface="Consolas" panose="020B0609020204030204" pitchFamily="49" charset="0"/>
-              </a:rPr>
-              <a:t>’</a:t>
+              <a:rPr lang="fr-FR" sz="1000" dirty="0">
+                <a:solidFill>
+                  <a:srgbClr val="98C379"/>
+                </a:solidFill>
+                <a:latin typeface="Consolas" panose="020B0609020204030204" pitchFamily="49" charset="0"/>
+              </a:rPr>
+              <a:t>'</a:t>
             </a:r>
             <a:r>
               <a:rPr lang="fr-FR" sz="1000" b="0" dirty="0">
@@ -18635,6 +18606,15 @@
 </file>
 
 <file path=customXml/item1.xml><?xml version="1.0" encoding="utf-8"?>
+<?mso-contentType ?>
+<FormTemplates xmlns="http://schemas.microsoft.com/sharepoint/v3/contenttype/forms">
+  <Display>DocumentLibraryForm</Display>
+  <Edit>DocumentLibraryForm</Edit>
+  <New>DocumentLibraryForm</New>
+</FormTemplates>
+</file>
+
+<file path=customXml/item2.xml><?xml version="1.0" encoding="utf-8"?>
 <p:properties xmlns:p="http://schemas.microsoft.com/office/2006/metadata/properties" xmlns:xsi="http://www.w3.org/2001/XMLSchema-instance" xmlns:pc="http://schemas.microsoft.com/office/infopath/2007/PartnerControls">
   <documentManagement>
     <SharedWithUsers xmlns="73eca01c-4ea5-40c8-83fd-b296bd340025">
@@ -18649,7 +18629,7 @@
 </p:properties>
 </file>
 
-<file path=customXml/item2.xml><?xml version="1.0" encoding="utf-8"?>
+<file path=customXml/item3.xml><?xml version="1.0" encoding="utf-8"?>
 <ct:contentTypeSchema xmlns:ct="http://schemas.microsoft.com/office/2006/metadata/contentType" xmlns:ma="http://schemas.microsoft.com/office/2006/metadata/properties/metaAttributes" ct:_="" ma:_="" ma:contentTypeName="Document" ma:contentTypeID="0x01010058419B1710D3DF4A9DAA9ADF73C802B5" ma:contentTypeVersion="14" ma:contentTypeDescription="Crée un document." ma:contentTypeScope="" ma:versionID="d45f398bd182fafaec1e6b20d8a38b6f">
   <xsd:schema xmlns:xsd="http://www.w3.org/2001/XMLSchema" xmlns:xs="http://www.w3.org/2001/XMLSchema" xmlns:p="http://schemas.microsoft.com/office/2006/metadata/properties" xmlns:ns3="6f1b3788-58c0-46a5-9604-64d97c7fc47c" xmlns:ns4="73eca01c-4ea5-40c8-83fd-b296bd340025" targetNamespace="http://schemas.microsoft.com/office/2006/metadata/properties" ma:root="true" ma:fieldsID="de746a5257d740f042749d495693305b" ns3:_="" ns4:_="">
     <xsd:import namespace="6f1b3788-58c0-46a5-9604-64d97c7fc47c"/>
@@ -18874,16 +18854,15 @@
 </ct:contentTypeSchema>
 </file>
 
-<file path=customXml/item3.xml><?xml version="1.0" encoding="utf-8"?>
-<?mso-contentType ?>
-<FormTemplates xmlns="http://schemas.microsoft.com/sharepoint/v3/contenttype/forms">
-  <Display>DocumentLibraryForm</Display>
-  <Edit>DocumentLibraryForm</Edit>
-  <New>DocumentLibraryForm</New>
-</FormTemplates>
+<file path=customXml/itemProps1.xml><?xml version="1.0" encoding="utf-8"?>
+<ds:datastoreItem xmlns:ds="http://schemas.openxmlformats.org/officeDocument/2006/customXml" ds:itemID="{EBAA46D8-DF31-4768-AD82-8F485C82E644}">
+  <ds:schemaRefs>
+    <ds:schemaRef ds:uri="http://schemas.microsoft.com/sharepoint/v3/contenttype/forms"/>
+  </ds:schemaRefs>
+</ds:datastoreItem>
 </file>
 
-<file path=customXml/itemProps1.xml><?xml version="1.0" encoding="utf-8"?>
+<file path=customXml/itemProps2.xml><?xml version="1.0" encoding="utf-8"?>
 <ds:datastoreItem xmlns:ds="http://schemas.openxmlformats.org/officeDocument/2006/customXml" ds:itemID="{40C00205-F11F-4D61-9572-D162BE7CE022}">
   <ds:schemaRefs>
     <ds:schemaRef ds:uri="http://schemas.microsoft.com/office/infopath/2007/PartnerControls"/>
@@ -18900,7 +18879,7 @@
 </ds:datastoreItem>
 </file>
 
-<file path=customXml/itemProps2.xml><?xml version="1.0" encoding="utf-8"?>
+<file path=customXml/itemProps3.xml><?xml version="1.0" encoding="utf-8"?>
 <ds:datastoreItem xmlns:ds="http://schemas.openxmlformats.org/officeDocument/2006/customXml" ds:itemID="{13D40C7A-64C6-4B3B-A1B6-9CB64BC75662}">
   <ds:schemaRefs>
     <ds:schemaRef ds:uri="http://schemas.microsoft.com/office/2006/metadata/contentType"/>
@@ -18917,12 +18896,4 @@
     <ds:schemaRef ds:uri="http://schemas.microsoft.com/internal/obd"/>
   </ds:schemaRefs>
 </ds:datastoreItem>
-</file>
-
-<file path=customXml/itemProps3.xml><?xml version="1.0" encoding="utf-8"?>
-<ds:datastoreItem xmlns:ds="http://schemas.openxmlformats.org/officeDocument/2006/customXml" ds:itemID="{EBAA46D8-DF31-4768-AD82-8F485C82E644}">
-  <ds:schemaRefs>
-    <ds:schemaRef ds:uri="http://schemas.microsoft.com/sharepoint/v3/contenttype/forms"/>
-  </ds:schemaRefs>
-</ds:datastoreItem>
 </file>
</xml_diff>